<commit_message>
Resize biology figures to match the slide embed box (no more tiny text)
Root cause: matplotlib figures were rendered at 14x8 inches but embedded
into an 8.20x4.85 inch box on the biology slides, halving apparent font
sizes (a 14pt label in the source PNG showed as ~8pt on the slide).

Regenerate at 10x5.92 inches (aspect 1.69 matches the embed box exactly)
at DPI 180, with font sizes chosen for the smaller canvas. Also shorten
the HPO-axis LH arrow label so it stops crossing into the "In PCOS"
bullet panel.

Co-Authored-By: Claude Opus 4.7 (1M context) <noreply@anthropic.com>
</commit_message>
<xml_diff>
--- a/presentation/pcos_pathfinder_deck.pptx
+++ b/presentation/pcos_pathfinder_deck.pptx
@@ -26817,8 +26817,8 @@
         </p:blipFill>
         <p:spPr>
           <a:xfrm>
-            <a:off x="502920" y="1922446"/>
-            <a:ext cx="7498079" cy="4430427"/>
+            <a:off x="802902" y="1920240"/>
+            <a:ext cx="6898114" cy="4434840"/>
           </a:xfrm>
           <a:prstGeom prst="rect">
             <a:avLst/>
@@ -27412,8 +27412,8 @@
         </p:blipFill>
         <p:spPr>
           <a:xfrm>
-            <a:off x="502920" y="2366284"/>
-            <a:ext cx="7498078" cy="3542752"/>
+            <a:off x="502920" y="2008968"/>
+            <a:ext cx="7498079" cy="4257383"/>
           </a:xfrm>
           <a:prstGeom prst="rect">
             <a:avLst/>
@@ -28007,8 +28007,8 @@
         </p:blipFill>
         <p:spPr>
           <a:xfrm>
-            <a:off x="922154" y="1920240"/>
-            <a:ext cx="6659610" cy="4434840"/>
+            <a:off x="879808" y="1920240"/>
+            <a:ext cx="6744303" cy="4434840"/>
           </a:xfrm>
           <a:prstGeom prst="rect">
             <a:avLst/>
@@ -28602,8 +28602,8 @@
         </p:blipFill>
         <p:spPr>
           <a:xfrm>
-            <a:off x="502920" y="1984843"/>
-            <a:ext cx="7498078" cy="4305633"/>
+            <a:off x="653882" y="1920240"/>
+            <a:ext cx="7196155" cy="4434840"/>
           </a:xfrm>
           <a:prstGeom prst="rect">
             <a:avLst/>
@@ -29197,8 +29197,8 @@
         </p:blipFill>
         <p:spPr>
           <a:xfrm>
-            <a:off x="666131" y="1920240"/>
-            <a:ext cx="7171656" cy="4434840"/>
+            <a:off x="601584" y="1920240"/>
+            <a:ext cx="7300750" cy="4434840"/>
           </a:xfrm>
           <a:prstGeom prst="rect">
             <a:avLst/>

</xml_diff>